<commit_message>
Remove retired graph product surface
</commit_message>
<xml_diff>
--- a/examples/project_review_deck_airworthiness/exports/rotor_llp_review_showcase.pptx
+++ b/examples/project_review_deck_airworthiness/exports/rotor_llp_review_showcase.pptx
@@ -21,9 +21,6 @@
     <p:sldId id="269" r:id="rId20"/>
     <p:sldId id="270" r:id="rId21"/>
     <p:sldId id="271" r:id="rId22"/>
-    <p:sldId id="272" r:id="rId23"/>
-    <p:sldId id="273" r:id="rId24"/>
-    <p:sldId id="274" r:id="rId25"/>
   </p:sldIdLst>
   <p:sldSz cx="12191999" cy="6858000" type="screen4x3"/>
   <p:notesSz cx="6858000" cy="9144000"/>
@@ -3194,7 +3191,7 @@
               <a:defRPr sz="1300"/>
             </a:pPr>
             <a:r>
-              <a:t>Workspaces: 3</a:t>
+              <a:t>Workspaces: 2</a:t>
             </a:r>
           </a:p>
           <a:p>
@@ -3251,7 +3248,7 @@
               <a:defRPr sz="2400" b="1"/>
             </a:pPr>
             <a:r>
-              <a:t>Evidence Binder / Ansys DPF Developer Docs / 08-ansys-dpf-developer-docs.png</a:t>
+              <a:t>Evidence Binder / PyAnsys Rotor 67 Thermal Strain / stress-hotspot-map.png</a:t>
             </a:r>
           </a:p>
         </p:txBody>
@@ -3289,7 +3286,7 @@
       </p:sp>
       <p:pic>
         <p:nvPicPr>
-          <p:cNvPr id="4" name="Project Review - Evidence Binder - Ansys DPF Developer Docs - 08-ansys-dpf-developer-docs.png" descr="08-ansys-dpf-developer-docs.png"/>
+          <p:cNvPr id="4" name="Project Review - Evidence Binder - PyAnsys Rotor 67 Thermal Strain - stress-hotspot-map.png" descr="stress-hotspot-map.png"/>
           <p:cNvPicPr>
             <a:picLocks noChangeAspect="1"/>
           </p:cNvPicPr>
@@ -3355,7 +3352,7 @@
               <a:defRPr sz="2400" b="1"/>
             </a:pPr>
             <a:r>
-              <a:t>Evidence Binder / EASA CM-PIFS-007 PDF - page 3 / cm-pifs-007-page-pdf-1.pdf</a:t>
+              <a:t>Evidence Binder / FAA AC 33.70-4 / 06-faa-ac-3370-4.png</a:t>
             </a:r>
           </a:p>
         </p:txBody>
@@ -3386,14 +3383,14 @@
               <a:defRPr sz="1200" b="0"/>
             </a:pPr>
             <a:r>
-              <a:t>PDF evidence</a:t>
+              <a:t>Image evidence</a:t>
             </a:r>
           </a:p>
         </p:txBody>
       </p:sp>
       <p:pic>
         <p:nvPicPr>
-          <p:cNvPr id="4" name="Project Review - Evidence Binder - EASA CM-PIFS-007 PDF - page 3 - cm-pifs-007-page-pdf-1.pdf" descr="02-easa-cm-pifs-007.png"/>
+          <p:cNvPr id="4" name="Project Review - Evidence Binder - FAA AC 33.70-4 - 06-faa-ac-3370-4.png" descr="06-faa-ac-3370-4.png"/>
           <p:cNvPicPr>
             <a:picLocks noChangeAspect="1"/>
           </p:cNvPicPr>
@@ -3407,45 +3404,14 @@
         </p:blipFill>
         <p:spPr>
           <a:xfrm>
-            <a:off x="4302861" y="1143000"/>
-            <a:ext cx="3586277" cy="5074920"/>
+            <a:off x="2724321" y="1143000"/>
+            <a:ext cx="6743357" cy="5303520"/>
           </a:xfrm>
           <a:prstGeom prst="rect">
             <a:avLst/>
           </a:prstGeom>
         </p:spPr>
       </p:pic>
-      <p:sp>
-        <p:nvSpPr>
-          <p:cNvPr id="5" name="TextBox 4"/>
-          <p:cNvSpPr txBox="1"/>
-          <p:nvPr/>
-        </p:nvSpPr>
-        <p:spPr>
-          <a:xfrm>
-            <a:off x="411480" y="6217920"/>
-            <a:ext cx="11369039" cy="228600"/>
-          </a:xfrm>
-          <a:prstGeom prst="rect">
-            <a:avLst/>
-          </a:prstGeom>
-          <a:noFill/>
-        </p:spPr>
-        <p:txBody>
-          <a:bodyPr wrap="none">
-            <a:spAutoFit/>
-          </a:bodyPr>
-          <a:lstStyle/>
-          <a:p>
-            <a:pPr algn="l">
-              <a:defRPr sz="900" b="0"/>
-            </a:pPr>
-            <a:r>
-              <a:t>PDF page 3 of 8</a:t>
-            </a:r>
-          </a:p>
-        </p:txBody>
-      </p:sp>
     </p:spTree>
   </p:cSld>
   <p:clrMapOvr>
@@ -3490,7 +3456,7 @@
               <a:defRPr sz="2400" b="1"/>
             </a:pPr>
             <a:r>
-              <a:t>Evidence Binder / PyAnsys Rotor 67 Total Deformation / displacement-envelope.png</a:t>
+              <a:t>Evidence Binder / FAA AC 33.70-1 PDF - page 2 / ac-33-70-1-life-limited-parts-chg-1.pdf</a:t>
             </a:r>
           </a:p>
         </p:txBody>
@@ -3521,14 +3487,14 @@
               <a:defRPr sz="1200" b="0"/>
             </a:pPr>
             <a:r>
-              <a:t>Image evidence</a:t>
+              <a:t>PDF evidence</a:t>
             </a:r>
           </a:p>
         </p:txBody>
       </p:sp>
       <p:pic>
         <p:nvPicPr>
-          <p:cNvPr id="4" name="Project Review - Evidence Binder - PyAnsys Rotor 67 Total Deformation - displacement-envelope.png" descr="displacement-envelope.png"/>
+          <p:cNvPr id="4" name="Project Review - Evidence Binder - FAA AC 33.70-1 PDF - page 2 - ac-33-70-1-life-limited-parts-ch" descr="Evidence Binder - FAA AC 33.70-1 PDF - page 2 - ac-33-70-1-life-limited-parts-chg-1.pdf-page-2.png"/>
           <p:cNvPicPr>
             <a:picLocks noChangeAspect="1"/>
           </p:cNvPicPr>
@@ -3542,14 +3508,45 @@
         </p:blipFill>
         <p:spPr>
           <a:xfrm>
-            <a:off x="1381760" y="1143000"/>
-            <a:ext cx="9428480" cy="5303520"/>
+            <a:off x="4135812" y="1143000"/>
+            <a:ext cx="3920376" cy="5074920"/>
           </a:xfrm>
           <a:prstGeom prst="rect">
             <a:avLst/>
           </a:prstGeom>
         </p:spPr>
       </p:pic>
+      <p:sp>
+        <p:nvSpPr>
+          <p:cNvPr id="5" name="TextBox 4"/>
+          <p:cNvSpPr txBox="1"/>
+          <p:nvPr/>
+        </p:nvSpPr>
+        <p:spPr>
+          <a:xfrm>
+            <a:off x="411480" y="6217920"/>
+            <a:ext cx="11369039" cy="228600"/>
+          </a:xfrm>
+          <a:prstGeom prst="rect">
+            <a:avLst/>
+          </a:prstGeom>
+          <a:noFill/>
+        </p:spPr>
+        <p:txBody>
+          <a:bodyPr wrap="none">
+            <a:spAutoFit/>
+          </a:bodyPr>
+          <a:lstStyle/>
+          <a:p>
+            <a:pPr algn="l">
+              <a:defRPr sz="900" b="0"/>
+            </a:pPr>
+            <a:r>
+              <a:t>PDF page 2 of 25</a:t>
+            </a:r>
+          </a:p>
+        </p:txBody>
+      </p:sp>
     </p:spTree>
   </p:cSld>
   <p:clrMapOvr>
@@ -3586,7 +3583,7 @@
         </p:spPr>
         <p:txBody>
           <a:bodyPr wrap="none">
-            <a:spAutoFit/>
+            <a:normAutofit fontScale="83920"/>
           </a:bodyPr>
           <a:lstStyle/>
           <a:p>
@@ -3594,7 +3591,7 @@
               <a:defRPr sz="2400" b="1"/>
             </a:pPr>
             <a:r>
-              <a:t>Evidence Binder / PyAnsys Rotor 67 Thermal Strain / stress-hotspot-map.png</a:t>
+              <a:t>Evidence Binder / Local Guide: FEA Evidence to CS-E Traceability / local-fea-traceability-guide-preview.png</a:t>
             </a:r>
           </a:p>
         </p:txBody>
@@ -3632,7 +3629,7 @@
       </p:sp>
       <p:pic>
         <p:nvPicPr>
-          <p:cNvPr id="4" name="Project Review - Evidence Binder - PyAnsys Rotor 67 Thermal Strain - stress-hotspot-map.png" descr="stress-hotspot-map.png"/>
+          <p:cNvPr id="4" name="Project Review - Evidence Binder - Local Guide- FEA Evidence to CS-E Traceability - local-fea-tra" descr="local-fea-traceability-guide-preview.png"/>
           <p:cNvPicPr>
             <a:picLocks noChangeAspect="1"/>
           </p:cNvPicPr>
@@ -3698,7 +3695,7 @@
               <a:defRPr sz="2400" b="1"/>
             </a:pPr>
             <a:r>
-              <a:t>Evidence Binder / FAA AC 33.70-4 / 06-faa-ac-3370-4.png</a:t>
+              <a:t>Evidence Binder / Margin Summary Chart / margin-summary-chart.png</a:t>
             </a:r>
           </a:p>
         </p:txBody>
@@ -3736,7 +3733,7 @@
       </p:sp>
       <p:pic>
         <p:nvPicPr>
-          <p:cNvPr id="4" name="Project Review - Evidence Binder - FAA AC 33.70-4 - 06-faa-ac-3370-4.png" descr="06-faa-ac-3370-4.png"/>
+          <p:cNvPr id="4" name="Project Review - Evidence Binder - Margin Summary Chart - margin-summary-chart.png" descr="margin-summary-chart.png"/>
           <p:cNvPicPr>
             <a:picLocks noChangeAspect="1"/>
           </p:cNvPicPr>
@@ -3750,8 +3747,8 @@
         </p:blipFill>
         <p:spPr>
           <a:xfrm>
-            <a:off x="2724321" y="1143000"/>
-            <a:ext cx="6743357" cy="5303520"/>
+            <a:off x="1728395" y="1143000"/>
+            <a:ext cx="8735209" cy="5303520"/>
           </a:xfrm>
           <a:prstGeom prst="rect">
             <a:avLst/>
@@ -3802,7 +3799,7 @@
               <a:defRPr sz="2400" b="1"/>
             </a:pPr>
             <a:r>
-              <a:t>Evidence Binder / FAA AC 33.70-1 PDF - page 2 / ac-33-70-1-life-limited-parts-chg-1.pdf</a:t>
+              <a:t>Evidence Binder / FAA AC 33.70-1 / 05-faa-ac-3370-1.png</a:t>
             </a:r>
           </a:p>
         </p:txBody>
@@ -3833,14 +3830,14 @@
               <a:defRPr sz="1200" b="0"/>
             </a:pPr>
             <a:r>
-              <a:t>PDF evidence</a:t>
+              <a:t>Image evidence</a:t>
             </a:r>
           </a:p>
         </p:txBody>
       </p:sp>
       <p:pic>
         <p:nvPicPr>
-          <p:cNvPr id="4" name="Project Review - Evidence Binder - FAA AC 33.70-1 PDF - page 2 - ac-33-70-1-life-limited-parts-ch" descr="Evidence Binder - FAA AC 33.70-1 PDF - page 2 - ac-33-70-1-life-limited-parts-chg-1.pdf-page-2.png"/>
+          <p:cNvPr id="4" name="Project Review - Evidence Binder - FAA AC 33.70-1 - 05-faa-ac-3370-1.png" descr="05-faa-ac-3370-1.png"/>
           <p:cNvPicPr>
             <a:picLocks noChangeAspect="1"/>
           </p:cNvPicPr>
@@ -3854,45 +3851,14 @@
         </p:blipFill>
         <p:spPr>
           <a:xfrm>
-            <a:off x="4135812" y="1143000"/>
-            <a:ext cx="3920376" cy="5074920"/>
+            <a:off x="2292988" y="1143000"/>
+            <a:ext cx="7606024" cy="5303520"/>
           </a:xfrm>
           <a:prstGeom prst="rect">
             <a:avLst/>
           </a:prstGeom>
         </p:spPr>
       </p:pic>
-      <p:sp>
-        <p:nvSpPr>
-          <p:cNvPr id="5" name="TextBox 4"/>
-          <p:cNvSpPr txBox="1"/>
-          <p:nvPr/>
-        </p:nvSpPr>
-        <p:spPr>
-          <a:xfrm>
-            <a:off x="411480" y="6217920"/>
-            <a:ext cx="11369039" cy="228600"/>
-          </a:xfrm>
-          <a:prstGeom prst="rect">
-            <a:avLst/>
-          </a:prstGeom>
-          <a:noFill/>
-        </p:spPr>
-        <p:txBody>
-          <a:bodyPr wrap="none">
-            <a:spAutoFit/>
-          </a:bodyPr>
-          <a:lstStyle/>
-          <a:p>
-            <a:pPr algn="l">
-              <a:defRPr sz="900" b="0"/>
-            </a:pPr>
-            <a:r>
-              <a:t>PDF page 2 of 25</a:t>
-            </a:r>
-          </a:p>
-        </p:txBody>
-      </p:sp>
     </p:spTree>
   </p:cSld>
   <p:clrMapOvr>
@@ -3937,7 +3903,7 @@
               <a:defRPr sz="2400" b="1"/>
             </a:pPr>
             <a:r>
-              <a:t>Evidence Binder / Local Guide: FEA Evidence to CS-E Traceability / local-fea-traceability-guide-preview.png</a:t>
+              <a:t>Project Files To Review</a:t>
             </a:r>
           </a:p>
         </p:txBody>
@@ -3968,63 +3934,21 @@
               <a:defRPr sz="1200" b="0"/>
             </a:pPr>
             <a:r>
-              <a:t>Image evidence</a:t>
-            </a:r>
-          </a:p>
-        </p:txBody>
-      </p:sp>
-      <p:pic>
-        <p:nvPicPr>
-          <p:cNvPr id="4" name="Project Review - Evidence Binder - Local Guide- FEA Evidence to CS-E Traceability - local-fea-tra" descr="local-fea-traceability-guide-preview.png"/>
-          <p:cNvPicPr>
-            <a:picLocks noChangeAspect="1"/>
-          </p:cNvPicPr>
-          <p:nvPr/>
-        </p:nvPicPr>
-        <p:blipFill>
-          <a:blip r:embed="rId2"/>
-          <a:stretch>
-            <a:fillRect/>
-          </a:stretch>
-        </p:blipFill>
-        <p:spPr>
-          <a:xfrm>
-            <a:off x="1381760" y="1143000"/>
-            <a:ext cx="9428480" cy="5303520"/>
-          </a:xfrm>
-          <a:prstGeom prst="rect">
-            <a:avLst/>
-          </a:prstGeom>
-        </p:spPr>
-      </p:pic>
-    </p:spTree>
-  </p:cSld>
-  <p:clrMapOvr>
-    <a:masterClrMapping/>
-  </p:clrMapOvr>
-</p:sld>
-</file>
-
-<file path=ppt/slides/slide17.xml><?xml version="1.0" encoding="utf-8"?>
-<p:sld xmlns:a="http://schemas.openxmlformats.org/drawingml/2006/main" xmlns:p="http://schemas.openxmlformats.org/presentationml/2006/main" xmlns:r="http://schemas.openxmlformats.org/officeDocument/2006/relationships">
-  <p:cSld>
-    <p:spTree>
-      <p:nvGrpSpPr>
-        <p:cNvPr id="1" name=""/>
-        <p:cNvGrpSpPr/>
-        <p:nvPr/>
-      </p:nvGrpSpPr>
-      <p:grpSpPr/>
-      <p:sp>
-        <p:nvSpPr>
-          <p:cNvPr id="2" name="TextBox 1"/>
+              <a:t>Missing, temporary, or unsupported evidence</a:t>
+            </a:r>
+          </a:p>
+        </p:txBody>
+      </p:sp>
+      <p:sp>
+        <p:nvSpPr>
+          <p:cNvPr id="4" name="TextBox 3"/>
           <p:cNvSpPr txBox="1"/>
           <p:nvPr/>
         </p:nvSpPr>
         <p:spPr>
           <a:xfrm>
-            <a:off x="411480" y="256032"/>
-            <a:ext cx="11369039" cy="457200"/>
+            <a:off x="411480" y="1143000"/>
+            <a:ext cx="11369039" cy="5303520"/>
           </a:xfrm>
           <a:prstGeom prst="rect">
             <a:avLst/>
@@ -4038,280 +3962,18 @@
           <a:lstStyle/>
           <a:p>
             <a:pPr algn="l">
-              <a:defRPr sz="2400" b="1"/>
+              <a:defRPr sz="1300"/>
             </a:pPr>
             <a:r>
-              <a:t>Evidence Binder / Margin Summary Chart / margin-summary-chart.png</a:t>
-            </a:r>
-          </a:p>
-        </p:txBody>
-      </p:sp>
-      <p:sp>
-        <p:nvSpPr>
-          <p:cNvPr id="3" name="TextBox 2"/>
-          <p:cNvSpPr txBox="1"/>
-          <p:nvPr/>
-        </p:nvSpPr>
-        <p:spPr>
-          <a:xfrm>
-            <a:off x="411480" y="749808"/>
-            <a:ext cx="11369039" cy="292608"/>
-          </a:xfrm>
-          <a:prstGeom prst="rect">
-            <a:avLst/>
-          </a:prstGeom>
-          <a:noFill/>
-        </p:spPr>
-        <p:txBody>
-          <a:bodyPr wrap="none">
-            <a:spAutoFit/>
-          </a:bodyPr>
-          <a:lstStyle/>
-          <a:p>
-            <a:pPr algn="l">
-              <a:defRPr sz="1200" b="0"/>
-            </a:pPr>
-            <a:r>
-              <a:t>Image evidence</a:t>
-            </a:r>
-          </a:p>
-        </p:txBody>
-      </p:sp>
-      <p:pic>
-        <p:nvPicPr>
-          <p:cNvPr id="4" name="Project Review - Evidence Binder - Margin Summary Chart - margin-summary-chart.png" descr="margin-summary-chart.png"/>
-          <p:cNvPicPr>
-            <a:picLocks noChangeAspect="1"/>
-          </p:cNvPicPr>
-          <p:nvPr/>
-        </p:nvPicPr>
-        <p:blipFill>
-          <a:blip r:embed="rId2"/>
-          <a:stretch>
-            <a:fillRect/>
-          </a:stretch>
-        </p:blipFill>
-        <p:spPr>
-          <a:xfrm>
-            <a:off x="1728395" y="1143000"/>
-            <a:ext cx="8735209" cy="5303520"/>
-          </a:xfrm>
-          <a:prstGeom prst="rect">
-            <a:avLst/>
-          </a:prstGeom>
-        </p:spPr>
-      </p:pic>
-    </p:spTree>
-  </p:cSld>
-  <p:clrMapOvr>
-    <a:masterClrMapping/>
-  </p:clrMapOvr>
-</p:sld>
-</file>
-
-<file path=ppt/slides/slide18.xml><?xml version="1.0" encoding="utf-8"?>
-<p:sld xmlns:a="http://schemas.openxmlformats.org/drawingml/2006/main" xmlns:p="http://schemas.openxmlformats.org/presentationml/2006/main" xmlns:r="http://schemas.openxmlformats.org/officeDocument/2006/relationships">
-  <p:cSld>
-    <p:spTree>
-      <p:nvGrpSpPr>
-        <p:cNvPr id="1" name=""/>
-        <p:cNvGrpSpPr/>
-        <p:nvPr/>
-      </p:nvGrpSpPr>
-      <p:grpSpPr/>
-      <p:sp>
-        <p:nvSpPr>
-          <p:cNvPr id="2" name="TextBox 1"/>
-          <p:cNvSpPr txBox="1"/>
-          <p:nvPr/>
-        </p:nvSpPr>
-        <p:spPr>
-          <a:xfrm>
-            <a:off x="411480" y="256032"/>
-            <a:ext cx="11369039" cy="457200"/>
-          </a:xfrm>
-          <a:prstGeom prst="rect">
-            <a:avLst/>
-          </a:prstGeom>
-          <a:noFill/>
-        </p:spPr>
-        <p:txBody>
-          <a:bodyPr wrap="none">
-            <a:spAutoFit/>
-          </a:bodyPr>
-          <a:lstStyle/>
-          <a:p>
-            <a:pPr algn="l">
-              <a:defRPr sz="2400" b="1"/>
-            </a:pPr>
-            <a:r>
-              <a:t>Evidence Binder / FAA AC 33.70-1 / 05-faa-ac-3370-1.png</a:t>
-            </a:r>
-          </a:p>
-        </p:txBody>
-      </p:sp>
-      <p:sp>
-        <p:nvSpPr>
-          <p:cNvPr id="3" name="TextBox 2"/>
-          <p:cNvSpPr txBox="1"/>
-          <p:nvPr/>
-        </p:nvSpPr>
-        <p:spPr>
-          <a:xfrm>
-            <a:off x="411480" y="749808"/>
-            <a:ext cx="11369039" cy="292608"/>
-          </a:xfrm>
-          <a:prstGeom prst="rect">
-            <a:avLst/>
-          </a:prstGeom>
-          <a:noFill/>
-        </p:spPr>
-        <p:txBody>
-          <a:bodyPr wrap="none">
-            <a:spAutoFit/>
-          </a:bodyPr>
-          <a:lstStyle/>
-          <a:p>
-            <a:pPr algn="l">
-              <a:defRPr sz="1200" b="0"/>
-            </a:pPr>
-            <a:r>
-              <a:t>Image evidence</a:t>
-            </a:r>
-          </a:p>
-        </p:txBody>
-      </p:sp>
-      <p:pic>
-        <p:nvPicPr>
-          <p:cNvPr id="4" name="Project Review - Evidence Binder - FAA AC 33.70-1 - 05-faa-ac-3370-1.png" descr="05-faa-ac-3370-1.png"/>
-          <p:cNvPicPr>
-            <a:picLocks noChangeAspect="1"/>
-          </p:cNvPicPr>
-          <p:nvPr/>
-        </p:nvPicPr>
-        <p:blipFill>
-          <a:blip r:embed="rId2"/>
-          <a:stretch>
-            <a:fillRect/>
-          </a:stretch>
-        </p:blipFill>
-        <p:spPr>
-          <a:xfrm>
-            <a:off x="2292988" y="1143000"/>
-            <a:ext cx="7606024" cy="5303520"/>
-          </a:xfrm>
-          <a:prstGeom prst="rect">
-            <a:avLst/>
-          </a:prstGeom>
-        </p:spPr>
-      </p:pic>
-    </p:spTree>
-  </p:cSld>
-  <p:clrMapOvr>
-    <a:masterClrMapping/>
-  </p:clrMapOvr>
-</p:sld>
-</file>
-
-<file path=ppt/slides/slide19.xml><?xml version="1.0" encoding="utf-8"?>
-<p:sld xmlns:a="http://schemas.openxmlformats.org/drawingml/2006/main" xmlns:p="http://schemas.openxmlformats.org/presentationml/2006/main" xmlns:r="http://schemas.openxmlformats.org/officeDocument/2006/relationships">
-  <p:cSld>
-    <p:spTree>
-      <p:nvGrpSpPr>
-        <p:cNvPr id="1" name=""/>
-        <p:cNvGrpSpPr/>
-        <p:nvPr/>
-      </p:nvGrpSpPr>
-      <p:grpSpPr/>
-      <p:sp>
-        <p:nvSpPr>
-          <p:cNvPr id="2" name="TextBox 1"/>
-          <p:cNvSpPr txBox="1"/>
-          <p:nvPr/>
-        </p:nvSpPr>
-        <p:spPr>
-          <a:xfrm>
-            <a:off x="411480" y="256032"/>
-            <a:ext cx="11369039" cy="457200"/>
-          </a:xfrm>
-          <a:prstGeom prst="rect">
-            <a:avLst/>
-          </a:prstGeom>
-          <a:noFill/>
-        </p:spPr>
-        <p:txBody>
-          <a:bodyPr wrap="none">
-            <a:spAutoFit/>
-          </a:bodyPr>
-          <a:lstStyle/>
-          <a:p>
-            <a:pPr algn="l">
-              <a:defRPr sz="2400" b="1"/>
-            </a:pPr>
-            <a:r>
-              <a:t>Project Files To Review</a:t>
-            </a:r>
-          </a:p>
-        </p:txBody>
-      </p:sp>
-      <p:sp>
-        <p:nvSpPr>
-          <p:cNvPr id="3" name="TextBox 2"/>
-          <p:cNvSpPr txBox="1"/>
-          <p:nvPr/>
-        </p:nvSpPr>
-        <p:spPr>
-          <a:xfrm>
-            <a:off x="411480" y="749808"/>
-            <a:ext cx="11369039" cy="292608"/>
-          </a:xfrm>
-          <a:prstGeom prst="rect">
-            <a:avLst/>
-          </a:prstGeom>
-          <a:noFill/>
-        </p:spPr>
-        <p:txBody>
-          <a:bodyPr wrap="none">
-            <a:spAutoFit/>
-          </a:bodyPr>
-          <a:lstStyle/>
-          <a:p>
-            <a:pPr algn="l">
-              <a:defRPr sz="1200" b="0"/>
-            </a:pPr>
-            <a:r>
-              <a:t>Missing, temporary, or unsupported evidence</a:t>
-            </a:r>
-          </a:p>
-        </p:txBody>
-      </p:sp>
-      <p:sp>
-        <p:nvSpPr>
-          <p:cNvPr id="4" name="TextBox 3"/>
-          <p:cNvSpPr txBox="1"/>
-          <p:nvPr/>
-        </p:nvSpPr>
-        <p:spPr>
-          <a:xfrm>
-            <a:off x="411480" y="1143000"/>
-            <a:ext cx="11369039" cy="5303520"/>
-          </a:xfrm>
-          <a:prstGeom prst="rect">
-            <a:avLst/>
-          </a:prstGeom>
-          <a:noFill/>
-        </p:spPr>
-        <p:txBody>
-          <a:bodyPr wrap="none">
-            <a:spAutoFit/>
-          </a:bodyPr>
-          <a:lstStyle/>
+              <a:t>Evidence Binder / Unsupported CSV Evidence Register / artifact: Media Panel source is invalid. The selected file is not a supported image, PDF, or video.</a:t>
+            </a:r>
+          </a:p>
           <a:p>
             <a:pPr algn="l">
               <a:defRPr sz="1300"/>
             </a:pPr>
             <a:r>
-              <a:t>DPF Evidence Canvases / DPF Stress Evidence - BOLT_NODES / file.rst: external file paths are listed but not embedded in Project Review Deck v1.</a:t>
+              <a:t>Evidence Binder / Unsupported Markdown Review Notes / artifact: Media Panel source is invalid. The selected file is not a supported image, PDF, or video.</a:t>
             </a:r>
           </a:p>
           <a:p>
@@ -4319,7 +3981,7 @@
               <a:defRPr sz="1300"/>
             </a:pPr>
             <a:r>
-              <a:t>DPF Evidence Canvases / DPF Displacement Evidence - BOLT_NODES / file.rst: external file paths are listed but not embedded in Project Review Deck v1.</a:t>
+              <a:t>Evidence Binder / Local Guide: FEA Evidence to CS-E Traceability / fea-evidence-to-cs-e-traceability.html: unsupported evidence file type '.html'.</a:t>
             </a:r>
           </a:p>
           <a:p>
@@ -4327,31 +3989,7 @@
               <a:defRPr sz="1300"/>
             </a:pPr>
             <a:r>
-              <a:t>Evidence Binder / Unsupported CSV Evidence Register / evidence-register.csv: unsupported evidence file type '.csv'.</a:t>
-            </a:r>
-          </a:p>
-          <a:p>
-            <a:pPr algn="l">
-              <a:defRPr sz="1300"/>
-            </a:pPr>
-            <a:r>
-              <a:t>Evidence Binder / Unsupported Markdown Review Notes / review-notes.md: unsupported evidence file type '.md'.</a:t>
-            </a:r>
-          </a:p>
-          <a:p>
-            <a:pPr algn="l">
-              <a:defRPr sz="1300"/>
-            </a:pPr>
-            <a:r>
-              <a:t>Evidence Binder / Local Guide: FEA Evidence to CS-E Traceability / fea-evidence-to-cs-e-traceability.html: unsupported evidence file type '.html'.</a:t>
-            </a:r>
-          </a:p>
-          <a:p>
-            <a:pPr algn="l">
-              <a:defRPr sz="1300"/>
-            </a:pPr>
-            <a:r>
-              <a:t>Evidence Binder / External Rig Evidence Placeholder / rotor_rig_strain.raw: external file paths are listed but not embedded in Project Review Deck v1.</a:t>
+              <a:t>Evidence Binder / External Rig Evidence Placeholder / artifact: Media Panel source is stale. The Media Panel source file could not be found.</a:t>
             </a:r>
           </a:p>
         </p:txBody>
@@ -4400,7 +4038,7 @@
               <a:defRPr sz="2400" b="1"/>
             </a:pPr>
             <a:r>
-              <a:t>Certification Review Map - Certification Review Map</a:t>
+              <a:t>Certification Review Map - Snapshot</a:t>
             </a:r>
           </a:p>
         </p:txBody>
@@ -4438,7 +4076,7 @@
       </p:sp>
       <p:pic>
         <p:nvPicPr>
-          <p:cNvPr id="4" name="Project Review - Certification Review Map - Certification Review Map" descr="corex-showcase-canvas-ws-certification-review-map-view_7185506706.png"/>
+          <p:cNvPr id="4" name="Project Review - Certification Review Map - Snapshot" descr="Certification Review Map-Certification Review Map - Snapshot.png"/>
           <p:cNvPicPr>
             <a:picLocks noChangeAspect="1"/>
           </p:cNvPicPr>
@@ -4452,8 +4090,8 @@
         </p:blipFill>
         <p:spPr>
           <a:xfrm>
-            <a:off x="1381760" y="1143000"/>
-            <a:ext cx="9428480" cy="5303520"/>
+            <a:off x="2324608" y="1143000"/>
+            <a:ext cx="7542784" cy="5303520"/>
           </a:xfrm>
           <a:prstGeom prst="rect">
             <a:avLst/>
@@ -4504,7 +4142,7 @@
               <a:defRPr sz="2400" b="1"/>
             </a:pPr>
             <a:r>
-              <a:t>DPF Evidence Canvases - DPF Evidence Canvases</a:t>
+              <a:t>Evidence Binder - Snapshot</a:t>
             </a:r>
           </a:p>
         </p:txBody>
@@ -4542,7 +4180,7 @@
       </p:sp>
       <p:pic>
         <p:nvPicPr>
-          <p:cNvPr id="4" name="Project Review - DPF Evidence Canvases - DPF Evidence Canvases" descr="corex-showcase-canvas-ws-dpf-evidence-canvases-view_56b295ade0.png"/>
+          <p:cNvPr id="4" name="Project Review - Evidence Binder - Snapshot" descr="Evidence Binder-Evidence Binder - Snapshot.png"/>
           <p:cNvPicPr>
             <a:picLocks noChangeAspect="1"/>
           </p:cNvPicPr>
@@ -4556,8 +4194,8 @@
         </p:blipFill>
         <p:spPr>
           <a:xfrm>
-            <a:off x="1381760" y="1143000"/>
-            <a:ext cx="9428480" cy="5303520"/>
+            <a:off x="1191010" y="1143000"/>
+            <a:ext cx="9809979" cy="5303520"/>
           </a:xfrm>
           <a:prstGeom prst="rect">
             <a:avLst/>
@@ -4608,7 +4246,7 @@
               <a:defRPr sz="2400" b="1"/>
             </a:pPr>
             <a:r>
-              <a:t>Evidence Binder - Evidence Binder</a:t>
+              <a:t>Certification Review Map / EASA CM-PIFS-013 / 03-easa-cm-pifs-013.png</a:t>
             </a:r>
           </a:p>
         </p:txBody>
@@ -4639,14 +4277,14 @@
               <a:defRPr sz="1200" b="0"/>
             </a:pPr>
             <a:r>
-              <a:t>Workspace canvas snapshot</a:t>
+              <a:t>Image evidence</a:t>
             </a:r>
           </a:p>
         </p:txBody>
       </p:sp>
       <p:pic>
         <p:nvPicPr>
-          <p:cNvPr id="4" name="Project Review - Evidence Binder - Evidence Binder" descr="corex-showcase-canvas-ws-evidence-binder-view_c40241c9aa.png"/>
+          <p:cNvPr id="4" name="Project Review - Certification Review Map - EASA CM-PIFS-013 - 03-easa-cm-pifs-013.png" descr="03-easa-cm-pifs-013.png"/>
           <p:cNvPicPr>
             <a:picLocks noChangeAspect="1"/>
           </p:cNvPicPr>
@@ -4660,8 +4298,8 @@
         </p:blipFill>
         <p:spPr>
           <a:xfrm>
-            <a:off x="1381760" y="1143000"/>
-            <a:ext cx="9428480" cy="5303520"/>
+            <a:off x="3091657" y="1143000"/>
+            <a:ext cx="6008685" cy="5303520"/>
           </a:xfrm>
           <a:prstGeom prst="rect">
             <a:avLst/>
@@ -4712,7 +4350,7 @@
               <a:defRPr sz="2400" b="1"/>
             </a:pPr>
             <a:r>
-              <a:t>Certification Review Map / EASA CM-PIFS-013 / 03-easa-cm-pifs-013.png</a:t>
+              <a:t>Certification Review Map / EASA CS-E Easy Access Rules / 01-easa-cs-e-easy-access-rules.png</a:t>
             </a:r>
           </a:p>
         </p:txBody>
@@ -4750,7 +4388,7 @@
       </p:sp>
       <p:pic>
         <p:nvPicPr>
-          <p:cNvPr id="4" name="Project Review - Certification Review Map - EASA CM-PIFS-013 - 03-easa-cm-pifs-013.png" descr="03-easa-cm-pifs-013.png"/>
+          <p:cNvPr id="4" name="Project Review - Certification Review Map - EASA CS-E Easy Access Rules - 01-easa-cs-e-easy-acces" descr="01-easa-cs-e-easy-access-rules.png"/>
           <p:cNvPicPr>
             <a:picLocks noChangeAspect="1"/>
           </p:cNvPicPr>
@@ -4764,8 +4402,8 @@
         </p:blipFill>
         <p:spPr>
           <a:xfrm>
-            <a:off x="3091657" y="1143000"/>
-            <a:ext cx="6008685" cy="5303520"/>
+            <a:off x="4010940" y="1143000"/>
+            <a:ext cx="4170120" cy="5303520"/>
           </a:xfrm>
           <a:prstGeom prst="rect">
             <a:avLst/>
@@ -4816,7 +4454,7 @@
               <a:defRPr sz="2400" b="1"/>
             </a:pPr>
             <a:r>
-              <a:t>Certification Review Map / EASA CS-E Easy Access Rules / 01-easa-cs-e-easy-access-rules.png</a:t>
+              <a:t>Certification Review Map / EASA CM-PIFS-007 / 02-easa-cm-pifs-007.png</a:t>
             </a:r>
           </a:p>
         </p:txBody>
@@ -4854,7 +4492,7 @@
       </p:sp>
       <p:pic>
         <p:nvPicPr>
-          <p:cNvPr id="4" name="Project Review - Certification Review Map - EASA CS-E Easy Access Rules - 01-easa-cs-e-easy-acces" descr="01-easa-cs-e-easy-access-rules.png"/>
+          <p:cNvPr id="4" name="Project Review - Certification Review Map - EASA CM-PIFS-007 - 02-easa-cm-pifs-007.png" descr="02-easa-cm-pifs-007.png"/>
           <p:cNvPicPr>
             <a:picLocks noChangeAspect="1"/>
           </p:cNvPicPr>
@@ -4868,8 +4506,8 @@
         </p:blipFill>
         <p:spPr>
           <a:xfrm>
-            <a:off x="4010940" y="1143000"/>
-            <a:ext cx="4170120" cy="5303520"/>
+            <a:off x="4222089" y="1143000"/>
+            <a:ext cx="3747821" cy="5303520"/>
           </a:xfrm>
           <a:prstGeom prst="rect">
             <a:avLst/>
@@ -4920,7 +4558,7 @@
               <a:defRPr sz="2400" b="1"/>
             </a:pPr>
             <a:r>
-              <a:t>Certification Review Map / EASA CM-PIFS-007 / 02-easa-cm-pifs-007.png</a:t>
+              <a:t>Certification Review Map / eCFR 14 CFR 33.70 / 04-ecfr-14-cfr-3370.png</a:t>
             </a:r>
           </a:p>
         </p:txBody>
@@ -4958,7 +4596,7 @@
       </p:sp>
       <p:pic>
         <p:nvPicPr>
-          <p:cNvPr id="4" name="Project Review - Certification Review Map - EASA CM-PIFS-007 - 02-easa-cm-pifs-007.png" descr="02-easa-cm-pifs-007.png"/>
+          <p:cNvPr id="4" name="Project Review - Certification Review Map - eCFR 14 CFR 33.70 - 04-ecfr-14-cfr-3370.png" descr="04-ecfr-14-cfr-3370.png"/>
           <p:cNvPicPr>
             <a:picLocks noChangeAspect="1"/>
           </p:cNvPicPr>
@@ -4972,8 +4610,8 @@
         </p:blipFill>
         <p:spPr>
           <a:xfrm>
-            <a:off x="4222089" y="1143000"/>
-            <a:ext cx="3747821" cy="5303520"/>
+            <a:off x="1853184" y="1143000"/>
+            <a:ext cx="8485632" cy="5303520"/>
           </a:xfrm>
           <a:prstGeom prst="rect">
             <a:avLst/>
@@ -5024,7 +4662,7 @@
               <a:defRPr sz="2400" b="1"/>
             </a:pPr>
             <a:r>
-              <a:t>Certification Review Map / eCFR 14 CFR 33.70 / 04-ecfr-14-cfr-3370.png</a:t>
+              <a:t>Evidence Binder / EASA CM-PIFS-007 PDF - page 3 / cm-pifs-007-page-pdf-1.pdf</a:t>
             </a:r>
           </a:p>
         </p:txBody>
@@ -5055,14 +4693,14 @@
               <a:defRPr sz="1200" b="0"/>
             </a:pPr>
             <a:r>
-              <a:t>Image evidence</a:t>
+              <a:t>PDF evidence</a:t>
             </a:r>
           </a:p>
         </p:txBody>
       </p:sp>
       <p:pic>
         <p:nvPicPr>
-          <p:cNvPr id="4" name="Project Review - Certification Review Map - eCFR 14 CFR 33.70 - 04-ecfr-14-cfr-3370.png" descr="04-ecfr-14-cfr-3370.png"/>
+          <p:cNvPr id="4" name="Project Review - Evidence Binder - EASA CM-PIFS-007 PDF - page 3 - cm-pifs-007-page-pdf-1.pdf" descr="Evidence Binder - EASA CM-PIFS-007 PDF - page 3 - cm-pifs-007-page-pdf-1.pdf-page-3.png"/>
           <p:cNvPicPr>
             <a:picLocks noChangeAspect="1"/>
           </p:cNvPicPr>
@@ -5076,14 +4714,45 @@
         </p:blipFill>
         <p:spPr>
           <a:xfrm>
-            <a:off x="1853184" y="1143000"/>
-            <a:ext cx="8485632" cy="5303520"/>
+            <a:off x="4302861" y="1143000"/>
+            <a:ext cx="3586277" cy="5074920"/>
           </a:xfrm>
           <a:prstGeom prst="rect">
             <a:avLst/>
           </a:prstGeom>
         </p:spPr>
       </p:pic>
+      <p:sp>
+        <p:nvSpPr>
+          <p:cNvPr id="5" name="TextBox 4"/>
+          <p:cNvSpPr txBox="1"/>
+          <p:nvPr/>
+        </p:nvSpPr>
+        <p:spPr>
+          <a:xfrm>
+            <a:off x="411480" y="6217920"/>
+            <a:ext cx="11369039" cy="228600"/>
+          </a:xfrm>
+          <a:prstGeom prst="rect">
+            <a:avLst/>
+          </a:prstGeom>
+          <a:noFill/>
+        </p:spPr>
+        <p:txBody>
+          <a:bodyPr wrap="none">
+            <a:spAutoFit/>
+          </a:bodyPr>
+          <a:lstStyle/>
+          <a:p>
+            <a:pPr algn="l">
+              <a:defRPr sz="900" b="0"/>
+            </a:pPr>
+            <a:r>
+              <a:t>PDF page 3 of 8</a:t>
+            </a:r>
+          </a:p>
+        </p:txBody>
+      </p:sp>
     </p:spTree>
   </p:cSld>
   <p:clrMapOvr>
@@ -5128,7 +4797,7 @@
               <a:defRPr sz="2400" b="1"/>
             </a:pPr>
             <a:r>
-              <a:t>Evidence Binder / PyDPF-Core User Guide / 07-pydpf-core-user-guide.png</a:t>
+              <a:t>Evidence Binder / PyAnsys Rotor 67 Total Deformation / displacement-envelope.png</a:t>
             </a:r>
           </a:p>
         </p:txBody>
@@ -5166,7 +4835,7 @@
       </p:sp>
       <p:pic>
         <p:nvPicPr>
-          <p:cNvPr id="4" name="Project Review - Evidence Binder - PyDPF-Core User Guide - 07-pydpf-core-user-guide.png" descr="07-pydpf-core-user-guide.png"/>
+          <p:cNvPr id="4" name="Project Review - Evidence Binder - PyAnsys Rotor 67 Total Deformation - displacement-envelope.png" descr="displacement-envelope.png"/>
           <p:cNvPicPr>
             <a:picLocks noChangeAspect="1"/>
           </p:cNvPicPr>

</xml_diff>